<commit_message>
Up to date screenshot
</commit_message>
<xml_diff>
--- a/Handouts/WhatWasSubmitted/TreeLabWorkAndGithubScreenshot.pptx
+++ b/Handouts/WhatWasSubmitted/TreeLabWorkAndGithubScreenshot.pptx
@@ -20901,7 +20901,7 @@
           <p:cNvPr id="3" name="Picture 2">
             <a:extLst>
               <a:ext uri="{FF2B5EF4-FFF2-40B4-BE49-F238E27FC236}">
-                <a16:creationId xmlns:a16="http://schemas.microsoft.com/office/drawing/2014/main" id="{BC1D5457-A0CF-6EEB-DD5E-76C9D784D5AE}"/>
+                <a16:creationId xmlns:a16="http://schemas.microsoft.com/office/drawing/2014/main" id="{1438A64E-F017-CC70-1359-7EF12791F1FD}"/>
               </a:ext>
             </a:extLst>
           </p:cNvPr>
@@ -20918,8 +20918,8 @@
         </p:blipFill>
         <p:spPr>
           <a:xfrm>
-            <a:off x="0" y="911310"/>
-            <a:ext cx="9144000" cy="5035379"/>
+            <a:off x="0" y="1063716"/>
+            <a:ext cx="9144000" cy="4730567"/>
           </a:xfrm>
           <a:prstGeom prst="rect">
             <a:avLst/>

</xml_diff>